<commit_message>
Update Funny Questions Activity Sp26.pptx
</commit_message>
<xml_diff>
--- a/DAEN460S26/C/Funny Questions Activity Sp26.pptx
+++ b/DAEN460S26/C/Funny Questions Activity Sp26.pptx
@@ -16,14 +16,14 @@
   <p:notesSz cx="6858000" cy="9144000"/>
   <p:embeddedFontLst>
     <p:embeddedFont>
-      <p:font typeface="Libre Franklin" pitchFamily="2" charset="0"/>
+      <p:font typeface="Libre Franklin" pitchFamily="2" charset="77"/>
       <p:regular r:id="rId6"/>
       <p:bold r:id="rId7"/>
       <p:italic r:id="rId8"/>
       <p:boldItalic r:id="rId9"/>
     </p:embeddedFont>
     <p:embeddedFont>
-      <p:font typeface="Libre Franklin Medium" pitchFamily="2" charset="0"/>
+      <p:font typeface="Libre Franklin Medium" pitchFamily="2" charset="77"/>
       <p:regular r:id="rId10"/>
       <p:bold r:id="rId11"/>
       <p:italic r:id="rId12"/>
@@ -264,7 +264,7 @@
       <p15:sldGuideLst xmlns:p15="http://schemas.microsoft.com/office/powerpoint/2012/main"/>
     </p:ext>
     <p:ext uri="GoogleSlidesCustomDataVersion2">
-      <go:slidesCustomData xmlns:go="http://customooxmlschemas.google.com/" xmlns:ahyp="http://schemas.microsoft.com/office/drawing/2018/hyperlinkcolor" xmlns:p15="http://schemas.microsoft.com/office/powerpoint/2012/main" xmlns:p14="http://schemas.microsoft.com/office/powerpoint/2010/main" xmlns:com="http://schemas.openxmlformats.org/drawingml/2006/compatibility" xmlns:pvml="urn:schemas-microsoft-com:office:powerpoint" xmlns:v="urn:schemas-microsoft-com:vml" xmlns:o="urn:schemas-microsoft-com:office:office" xmlns:dgm="http://schemas.openxmlformats.org/drawingml/2006/diagram" xmlns:c="http://schemas.openxmlformats.org/drawingml/2006/chart" xmlns:mv="urn:schemas-microsoft-com:mac:vml" xmlns:mc="http://schemas.openxmlformats.org/markup-compatibility/2006" xmlns="" r:id="rId17" roundtripDataSignature="AMtx7mhZzCuMi8F0uN2jrt8O9XisJRNQmA=="/>
+      <go:slidesCustomData xmlns="" xmlns:mc="http://schemas.openxmlformats.org/markup-compatibility/2006" xmlns:mv="urn:schemas-microsoft-com:mac:vml" xmlns:c="http://schemas.openxmlformats.org/drawingml/2006/chart" xmlns:dgm="http://schemas.openxmlformats.org/drawingml/2006/diagram" xmlns:o="urn:schemas-microsoft-com:office:office" xmlns:v="urn:schemas-microsoft-com:vml" xmlns:pvml="urn:schemas-microsoft-com:office:powerpoint" xmlns:com="http://schemas.openxmlformats.org/drawingml/2006/compatibility" xmlns:p14="http://schemas.microsoft.com/office/powerpoint/2010/main" xmlns:p15="http://schemas.microsoft.com/office/powerpoint/2012/main" xmlns:ahyp="http://schemas.microsoft.com/office/drawing/2018/hyperlinkcolor" xmlns:go="http://customooxmlschemas.google.com/" r:id="rId17" roundtripDataSignature="AMtx7mhZzCuMi8F0uN2jrt8O9XisJRNQmA=="/>
     </p:ext>
   </p:extLst>
 </p:presentation>
@@ -3425,7 +3425,13 @@
       </p:sp>
       <p:pic>
         <p:nvPicPr>
-          <p:cNvPr id="25" name="Google Shape;25;p26" descr="16x9PPBackground.psd"/>
+          <p:cNvPr id="25" name="Google Shape;25;p26">
+            <a:extLst>
+              <a:ext uri="{C183D7F6-B498-43B3-948B-1728B52AA6E4}">
+                <adec:decorative xmlns:adec="http://schemas.microsoft.com/office/drawing/2017/decorative" val="1"/>
+              </a:ext>
+            </a:extLst>
+          </p:cNvPr>
           <p:cNvPicPr preferRelativeResize="0"/>
           <p:nvPr/>
         </p:nvPicPr>
@@ -4089,7 +4095,13 @@
       </p:sp>
       <p:sp>
         <p:nvSpPr>
-          <p:cNvPr id="13" name="Google Shape;13;p25"/>
+          <p:cNvPr id="13" name="Google Shape;13;p25">
+            <a:extLst>
+              <a:ext uri="{C183D7F6-B498-43B3-948B-1728B52AA6E4}">
+                <adec:decorative xmlns:adec="http://schemas.microsoft.com/office/drawing/2017/decorative" val="1"/>
+              </a:ext>
+            </a:extLst>
+          </p:cNvPr>
           <p:cNvSpPr txBox="1"/>
           <p:nvPr/>
         </p:nvSpPr>
@@ -4130,7 +4142,7 @@
               <a:buNone/>
             </a:pPr>
             <a:r>
-              <a:rPr lang="en-US" sz="1333" b="0" i="0" u="none" strike="noStrike" cap="none">
+              <a:rPr lang="en-US" sz="1333" b="0" i="0" u="none" strike="noStrike" cap="none" dirty="0">
                 <a:solidFill>
                   <a:srgbClr val="FFFFFF"/>
                 </a:solidFill>
@@ -4141,7 +4153,7 @@
               </a:rPr>
               <a:t>Wm Michael Barnes ’64 Department of Industrial and Systems Engineering </a:t>
             </a:r>
-            <a:endParaRPr sz="1867" b="0" i="0" u="none" strike="noStrike" cap="none">
+            <a:endParaRPr sz="1867" b="0" i="0" u="none" strike="noStrike" cap="none" dirty="0">
               <a:solidFill>
                 <a:srgbClr val="000000"/>
               </a:solidFill>
@@ -4691,7 +4703,13 @@
       </p:sp>
       <p:pic>
         <p:nvPicPr>
-          <p:cNvPr id="16" name="Google Shape;16;p25"/>
+          <p:cNvPr id="16" name="Google Shape;16;p25">
+            <a:extLst>
+              <a:ext uri="{C183D7F6-B498-43B3-948B-1728B52AA6E4}">
+                <adec:decorative xmlns:adec="http://schemas.microsoft.com/office/drawing/2017/decorative" val="1"/>
+              </a:ext>
+            </a:extLst>
+          </p:cNvPr>
           <p:cNvPicPr preferRelativeResize="0"/>
           <p:nvPr/>
         </p:nvPicPr>

</xml_diff>